<commit_message>
docs: sync to 24 actions (kg pipeline + wtf-p workflows) + rebuild deck
README/RUNBOOK/USAGE updated to 24 actions: 5 new wtf-p workflows (research,
verify_work, check_refs, section_review, audit) with full flag tables + entries,
the kg --full/--stages/--resume pipeline, and the SectionOutline research fields.
CHANGELOG Unreleased updated; deck (AUTHOR.pptx/pdf) rebuilt to 24 actions with
the new capabilities. Fixed stale RUNBOOK health-check numbers (532 tests, 69 files).

Co-Authored-By: Claude Opus 4.8 (1M context) <noreply@anthropic.com>
</commit_message>
<xml_diff>
--- a/docs/AUTHOR.pptx
+++ b/docs/AUTHOR.pptx
@@ -3237,7 +3237,7 @@
                   <a:srgbClr val="2E7D32"/>
                 </a:solidFill>
               </a:rPr>
-              <a:t>Invoked by the CLIO agent as a subagent   .   19 actions   .   grounded, not hallucinated</a:t>
+              <a:t>Invoked by the CLIO agent as a subagent   .   24 actions   .   grounded, not hallucinated</a:t>
             </a:r>
           </a:p>
         </p:txBody>
@@ -4447,7 +4447,7 @@
                   <a:srgbClr val="444444"/>
                 </a:solidFill>
               </a:rPr>
-              <a:t> 19 actions . ~470 hermetic tests + CI . live-validated (Claude/Codex/Ollama/Gemini, real citation backends) . motivation + benchmark plan . dynamic orchestrate.</a:t>
+              <a:t> 24 actions . ~470 hermetic tests + CI . live-validated (Claude/Codex/Ollama/Gemini, real citation backends) . motivation + benchmark plan . dynamic orchestrate.</a:t>
             </a:r>
           </a:p>
           <a:p>
@@ -4779,7 +4779,7 @@
                   <a:srgbClr val="444444"/>
                 </a:solidFill>
               </a:rPr>
-              <a:t> built end-to-end - 19 actions, ~470 hermetic tests, CI green; validated live (Claude / Codex / Ollama / Gemini vision / live citation backends).</a:t>
+              <a:t> built end-to-end - 24 actions, ~530 hermetic tests, CI green; validated live (Claude / Codex / Ollama / Gemini vision / live citation backends).</a:t>
             </a:r>
           </a:p>
         </p:txBody>
@@ -7957,7 +7957,7 @@
                   <a:srgbClr val="FFFFFF"/>
                 </a:solidFill>
               </a:rPr>
-              <a:t>5 . What we built - the 19 actions</a:t>
+              <a:t>5 . What we built - the 24 actions</a:t>
             </a:r>
           </a:p>
         </p:txBody>
@@ -8105,7 +8105,7 @@
                   <a:srgbClr val="444444"/>
                 </a:solidFill>
               </a:rPr>
-              <a:t> plan (tasks/claims/sources), write, edit, polish, coherence, compose (whole paper), export (-&gt; LaTeX)</a:t>
+              <a:t> plan, write, edit, polish, coherence, compose (whole paper), export (-&gt; LaTeX)</a:t>
             </a:r>
           </a:p>
           <a:p>
@@ -8129,6 +8129,52 @@
                 </a:solidFill>
               </a:rPr>
               <a:t> plot, describe_figures (Gemini vision), figure_refine (loop)</a:t>
+            </a:r>
+          </a:p>
+          <a:p>
+            <a:pPr>
+              <a:spcAft>
+                <a:spcPts val="700"/>
+              </a:spcAft>
+            </a:pPr>
+            <a:r>
+              <a:rPr b="1" sz="1600">
+                <a:solidFill>
+                  <a:srgbClr val="1F3A5F"/>
+                </a:solidFill>
+              </a:rPr>
+              <a:t>-  Research/verify:</a:t>
+            </a:r>
+            <a:r>
+              <a:rPr sz="1600">
+                <a:solidFill>
+                  <a:srgbClr val="444444"/>
+                </a:solidFill>
+              </a:rPr>
+              <a:t> research (grounded lit brief), verify_work (claim coverage), check_refs (BibTeX audit), section_review (3-layer), audit (pre-submission)</a:t>
+            </a:r>
+          </a:p>
+          <a:p>
+            <a:pPr>
+              <a:spcAft>
+                <a:spcPts val="700"/>
+              </a:spcAft>
+            </a:pPr>
+            <a:r>
+              <a:rPr b="1" sz="1600">
+                <a:solidFill>
+                  <a:srgbClr val="1F3A5F"/>
+                </a:solidFill>
+              </a:rPr>
+              <a:t>-  Knowledge graph:</a:t>
+            </a:r>
+            <a:r>
+              <a:rPr sz="1600">
+                <a:solidFill>
+                  <a:srgbClr val="444444"/>
+                </a:solidFill>
+              </a:rPr>
+              <a:t> kg (single-shot) and kg --full (6-stage pipeline: ontology-&gt;extraction-&gt;coref-&gt;verification, clean-room protoneo)</a:t>
             </a:r>
           </a:p>
           <a:p>

</xml_diff>

<commit_message>
docs: reorganize README by workflow; document discover + --pdf; 25 actions
README capabilities now grouped by workflow (read/understand/discover-verify/
review/write-compose/illustrate/export/orchestrate), each action with its
arguments + a runnable example. Documented discover + export/compose --pdf
across README/RUNBOOK/USAGE/INTEGRATION/SOURCE-COVERAGE (25 actions); flipped the
two PaperOrchestra gap rows (web discovery, PDF compile) to covered. CHANGELOG
updated; deck (AUTHOR.pptx/pdf) rebuilt to 25 actions.

Co-Authored-By: Claude Opus 4.8 (1M context) <noreply@anthropic.com>
</commit_message>
<xml_diff>
--- a/docs/AUTHOR.pptx
+++ b/docs/AUTHOR.pptx
@@ -3237,7 +3237,7 @@
                   <a:srgbClr val="2E7D32"/>
                 </a:solidFill>
               </a:rPr>
-              <a:t>Invoked by the CLIO agent as a subagent   .   24 actions   .   grounded, not hallucinated</a:t>
+              <a:t>Invoked by the CLIO agent as a subagent   .   25 actions   .   grounded, not hallucinated</a:t>
             </a:r>
           </a:p>
         </p:txBody>
@@ -4447,7 +4447,7 @@
                   <a:srgbClr val="444444"/>
                 </a:solidFill>
               </a:rPr>
-              <a:t> 24 actions . ~470 hermetic tests + CI . live-validated (Claude/Codex/Ollama/Gemini, real citation backends) . motivation + benchmark plan . dynamic orchestrate.</a:t>
+              <a:t> 25 actions . ~470 hermetic tests + CI . live-validated (Claude/Codex/Ollama/Gemini, real citation backends) . motivation + benchmark plan . dynamic orchestrate.</a:t>
             </a:r>
           </a:p>
           <a:p>
@@ -4779,7 +4779,7 @@
                   <a:srgbClr val="444444"/>
                 </a:solidFill>
               </a:rPr>
-              <a:t> built end-to-end - 24 actions, ~530 hermetic tests, CI green; validated live (Claude / Codex / Ollama / Gemini vision / live citation backends).</a:t>
+              <a:t> built end-to-end - 25 actions, ~556 hermetic tests, CI green; validated live (Claude / Codex / Ollama / Gemini vision / live citation backends).</a:t>
             </a:r>
           </a:p>
         </p:txBody>
@@ -7957,7 +7957,7 @@
                   <a:srgbClr val="FFFFFF"/>
                 </a:solidFill>
               </a:rPr>
-              <a:t>5 . What we built - the 24 actions</a:t>
+              <a:t>5 . What we built - the 25 actions</a:t>
             </a:r>
           </a:p>
         </p:txBody>
@@ -8051,7 +8051,7 @@
                   <a:srgbClr val="1F3A5F"/>
                 </a:solidFill>
               </a:rPr>
-              <a:t>-  Verify:</a:t>
+              <a:t>-  Discover/verify:</a:t>
             </a:r>
             <a:r>
               <a:rPr sz="1600">
@@ -8059,7 +8059,7 @@
                   <a:srgbClr val="444444"/>
                 </a:solidFill>
               </a:rPr>
-              <a:t> cite (Semantic Scholar -&gt; OpenAlex -&gt; Crossref -&gt; arXiv cascade; suggestions only, never edits)</a:t>
+              <a:t> discover (find real papers via scholarly search), cite (verify; 4-source cascade), check_refs (BibTeX audit)</a:t>
             </a:r>
           </a:p>
           <a:p>
@@ -8105,7 +8105,7 @@
                   <a:srgbClr val="444444"/>
                 </a:solidFill>
               </a:rPr>
-              <a:t> plan, write, edit, polish, coherence, compose (whole paper), export (-&gt; LaTeX)</a:t>
+              <a:t> plan, write, edit, polish, coherence, compose (whole paper), export (-&gt; LaTeX + PDF via --pdf)</a:t>
             </a:r>
           </a:p>
           <a:p>

</xml_diff>